<commit_message>
Add 境養・歸心・煥生 subtitle to title slide
Co-Authored-By: Claude Opus 5.5 <noreply@anthropic.com>
Claude-Session: https://claude.ai/code/session_019koV41QHXrLyXuEfvuae5F
</commit_message>
<xml_diff>
--- a/雲水歸心_康復療癒酒店整體設計規劃.pptx
+++ b/雲水歸心_康復療癒酒店整體設計規劃.pptx
@@ -120,31 +120,31 @@
   <p:extLst>
     <p:ext uri="{521415D9-36F7-43E2-AB2F-B90AF26B5E84}">
       <p14:sectionLst xmlns:p14="http://schemas.microsoft.com/office/powerpoint/2010/main">
-        <p14:section name="開場" id="{15641afa-7660-cf41-3d73-bb54493c540a}">
+        <p14:section name="開場" id="{19ebd3fd-42c0-6813-a766-ee0ad19a846f}">
           <p14:sldIdLst>
             <p14:sldId id="256"/>
           </p14:sldIdLst>
         </p14:section>
-        <p14:section name="定位" id="{54432580-d67e-a750-3a15-ce1ba695b15a}">
+        <p14:section name="定位" id="{21a29f4a-f7a6-dfba-b75e-673799c59abc}">
           <p14:sldIdLst>
             <p14:sldId id="257"/>
             <p14:sldId id="258"/>
             <p14:sldId id="259"/>
           </p14:sldIdLst>
         </p14:section>
-        <p14:section name="空間與服務" id="{142b033a-00f0-fdff-e60c-2bfe734b844e}">
+        <p14:section name="空間與服務" id="{1ae55e7f-3923-4816-5d63-a5a842e8069a}">
           <p14:sldIdLst>
             <p14:sldId id="260"/>
             <p14:sldId id="261"/>
           </p14:sldIdLst>
         </p14:section>
-        <p14:section name="品牌與客群" id="{1ab22399-0cad-d73a-8601-84ab29a645e0}">
+        <p14:section name="品牌與客群" id="{f3afe440-8736-1f84-260a-f4bdbb7fcc14}">
           <p14:sldIdLst>
             <p14:sldId id="262"/>
             <p14:sldId id="263"/>
           </p14:sldIdLst>
         </p14:section>
-        <p14:section name="療程設計" id="{bfc31190-9bfa-d387-589d-c9a3638ca87a}">
+        <p14:section name="療程設計" id="{39f2ab65-8b62-23c6-8710-22e5b1ff4f51}">
           <p14:sldIdLst>
             <p14:sldId id="264"/>
             <p14:sldId id="265"/>
@@ -153,7 +153,7 @@
             <p14:sldId id="268"/>
           </p14:sldIdLst>
         </p14:section>
-        <p14:section name="合作價值" id="{3e577609-0903-889a-9000-f1664d518ce4}">
+        <p14:section name="合作價值" id="{e3153c8d-4bc9-c8e8-f79f-7f9ba8c3baa8}">
           <p14:sldIdLst>
             <p14:sldId id="269"/>
           </p14:sldIdLst>
@@ -2465,12 +2465,29 @@
           <a:p>
             <a:pPr indent="0" marL="0">
               <a:lnSpc>
-                <a:spcPts val="2200"/>
-              </a:lnSpc>
-              <a:buNone/>
-            </a:pPr>
-            <a:r>
-              <a:rPr lang="en-US" sz="2200" b="1" dirty="0">
+                <a:spcPts val="3400"/>
+              </a:lnSpc>
+              <a:buNone/>
+            </a:pPr>
+            <a:r>
+              <a:rPr lang="en-US" sz="2200" b="1" spc="600" kern="0" dirty="0">
+                <a:solidFill>
+                  <a:schemeClr val="accent2"/>
+                </a:solidFill>
+              </a:rPr>
+              <a:t>境養・歸心・煥生</a:t>
+            </a:r>
+            <a:endParaRPr lang="en-US" sz="1600" dirty="0"/>
+          </a:p>
+          <a:p>
+            <a:pPr indent="0" marL="0">
+              <a:lnSpc>
+                <a:spcPts val="2800"/>
+              </a:lnSpc>
+              <a:buNone/>
+            </a:pPr>
+            <a:r>
+              <a:rPr lang="en-US" sz="1800" b="1" dirty="0">
                 <a:solidFill>
                   <a:schemeClr val="bg1"/>
                 </a:solidFill>

</xml_diff>